<commit_message>
Add post-announcement addendum; update README, FINAL_REVIEW, source log and pitch deck
Co-Authored-By: Claude Sonnet 5.5 <noreply@anthropic.com>
</commit_message>
<xml_diff>
--- a/07_Pitch_Deck/Project_Southeast_Asia_Sell_Side_Pitch.pptx
+++ b/07_Pitch_Deck/Project_Southeast_Asia_Sell_Side_Pitch.pptx
@@ -22,6 +22,8 @@
     <p:sldId id="270" r:id="rId16"/>
     <p:sldId id="271" r:id="rId17"/>
     <p:sldId id="272" r:id="rId18"/>
+    <p:sldId id="273" r:id="rId24"/>
+    <p:sldId id="274" r:id="rId25"/>
   </p:sldIdLst>
   <p:notesMasterIdLst>
     <p:notesMasterId r:id="rId19"/>
@@ -1659,6 +1661,283 @@
     </a:ln>
     <a:effectLst/>
   </c:spPr>
+  <c:externalData r:id="rId1">
+    <c:autoUpdate val="0"/>
+  </c:externalData>
+</c:chartSpace>
+</file>
+
+<file path=ppt/charts/chart6.xml><?xml version="1.0" encoding="utf-8"?>
+<c:chartSpace xmlns:c="http://schemas.openxmlformats.org/drawingml/2006/chart" xmlns:a="http://schemas.openxmlformats.org/drawingml/2006/main" xmlns:r="http://schemas.openxmlformats.org/officeDocument/2006/relationships">
+  <c:date1904 val="0"/>
+  <c:chart>
+    <c:autoTitleDeleted val="1"/>
+    <c:plotArea>
+      <c:barChart>
+        <c:barDir val="bar"/>
+        <c:grouping val="stacked"/>
+        <c:ser>
+          <c:idx val="0"/>
+          <c:order val="0"/>
+          <c:tx>
+            <c:strRef>
+              <c:f>Sheet1!$B$1</c:f>
+              <c:strCache>
+                <c:ptCount val="1"/>
+                <c:pt idx="0">
+                  <c:v>Base</c:v>
+                </c:pt>
+              </c:strCache>
+            </c:strRef>
+          </c:tx>
+          <c:spPr>
+            <a:noFill/>
+            <a:ln>
+              <a:noFill/>
+            </a:ln>
+          </c:spPr>
+          <c:cat>
+            <c:strRef>
+              <c:f>Sheet1!$A$2:$A$6</c:f>
+              <c:strCache>
+                <c:ptCount val="5"/>
+                <c:pt idx="0">
+                  <c:v>Announced EV
+1,200</c:v>
+                </c:pt>
+                <c:pt idx="1">
+                  <c:v>Comps EV/Revenue *
+468-1,063</c:v>
+                </c:pt>
+                <c:pt idx="2">
+                  <c:v>Comps EV/EBITDA *
+594-1,511</c:v>
+                </c:pt>
+                <c:pt idx="3">
+                  <c:v>DCF sensitivity
+468-908</c:v>
+                </c:pt>
+                <c:pt idx="4">
+                  <c:v>Recommended range
+500-775</c:v>
+                </c:pt>
+              </c:strCache>
+            </c:strRef>
+          </c:cat>
+          <c:val>
+            <c:numRef>
+              <c:f>Sheet1!$B$2:$B$6</c:f>
+              <c:numCache>
+                <c:formatCode>General</c:formatCode>
+                <c:ptCount val="5"/>
+                <c:pt idx="0">
+                  <c:v>1185</c:v>
+                </c:pt>
+                <c:pt idx="1">
+                  <c:v>468</c:v>
+                </c:pt>
+                <c:pt idx="2">
+                  <c:v>594</c:v>
+                </c:pt>
+                <c:pt idx="3">
+                  <c:v>468</c:v>
+                </c:pt>
+                <c:pt idx="4">
+                  <c:v>500</c:v>
+                </c:pt>
+              </c:numCache>
+            </c:numRef>
+          </c:val>
+        </c:ser>
+        <c:ser>
+          <c:idx val="1"/>
+          <c:order val="1"/>
+          <c:tx>
+            <c:strRef>
+              <c:f>Sheet1!$C$1</c:f>
+              <c:strCache>
+                <c:ptCount val="1"/>
+                <c:pt idx="0">
+                  <c:v>Range (EUR m)</c:v>
+                </c:pt>
+              </c:strCache>
+            </c:strRef>
+          </c:tx>
+          <c:spPr>
+            <a:solidFill>
+              <a:srgbClr val="1E2761"/>
+            </a:solidFill>
+            <a:ln>
+              <a:noFill/>
+            </a:ln>
+          </c:spPr>
+          <c:dPt>
+            <c:idx val="0"/>
+            <c:spPr>
+              <a:solidFill>
+                <a:srgbClr val="C9A227"/>
+              </a:solidFill>
+            </c:spPr>
+          </c:dPt>
+          <c:cat>
+            <c:strRef>
+              <c:f>Sheet1!$A$2:$A$6</c:f>
+              <c:strCache>
+                <c:ptCount val="5"/>
+                <c:pt idx="0">
+                  <c:v>Announced EV
+1,200</c:v>
+                </c:pt>
+                <c:pt idx="1">
+                  <c:v>Comps EV/Revenue *
+468-1,063</c:v>
+                </c:pt>
+                <c:pt idx="2">
+                  <c:v>Comps EV/EBITDA *
+594-1,511</c:v>
+                </c:pt>
+                <c:pt idx="3">
+                  <c:v>DCF sensitivity
+468-908</c:v>
+                </c:pt>
+                <c:pt idx="4">
+                  <c:v>Recommended range
+500-775</c:v>
+                </c:pt>
+              </c:strCache>
+            </c:strRef>
+          </c:cat>
+          <c:val>
+            <c:numRef>
+              <c:f>Sheet1!$C$2:$C$6</c:f>
+              <c:numCache>
+                <c:formatCode>General</c:formatCode>
+                <c:ptCount val="5"/>
+                <c:pt idx="0">
+                  <c:v>30</c:v>
+                </c:pt>
+                <c:pt idx="1">
+                  <c:v>595</c:v>
+                </c:pt>
+                <c:pt idx="2">
+                  <c:v>917</c:v>
+                </c:pt>
+                <c:pt idx="3">
+                  <c:v>440</c:v>
+                </c:pt>
+                <c:pt idx="4">
+                  <c:v>275</c:v>
+                </c:pt>
+              </c:numCache>
+            </c:numRef>
+          </c:val>
+        </c:ser>
+        <c:gapWidth val="55"/>
+        <c:overlap val="100"/>
+        <c:axId val="-2068027336"/>
+        <c:axId val="-2113994440"/>
+      </c:barChart>
+      <c:catAx>
+        <c:axId val="-2068027336"/>
+        <c:scaling>
+          <c:orientation val="minMax"/>
+        </c:scaling>
+        <c:delete val="0"/>
+        <c:axPos val="l"/>
+        <c:majorTickMark val="out"/>
+        <c:minorTickMark val="none"/>
+        <c:tickLblPos val="nextTo"/>
+        <c:spPr>
+          <a:ln>
+            <a:solidFill>
+              <a:srgbClr val="BFC4D2"/>
+            </a:solidFill>
+          </a:ln>
+        </c:spPr>
+        <c:txPr>
+          <a:bodyPr/>
+          <a:lstStyle/>
+          <a:p>
+            <a:pPr>
+              <a:defRPr sz="1000"/>
+            </a:pPr>
+          </a:p>
+        </c:txPr>
+        <c:crossAx val="-2113994440"/>
+        <c:crosses val="autoZero"/>
+        <c:auto val="1"/>
+        <c:lblAlgn val="ctr"/>
+        <c:lblOffset val="100"/>
+        <c:noMultiLvlLbl val="0"/>
+      </c:catAx>
+      <c:valAx>
+        <c:axId val="-2113994440"/>
+        <c:scaling>
+          <c:max val="1600.0"/>
+          <c:min val="0.0"/>
+        </c:scaling>
+        <c:delete val="0"/>
+        <c:axPos val="b"/>
+        <c:majorGridlines>
+          <c:spPr>
+            <a:ln>
+              <a:solidFill>
+                <a:srgbClr val="E3E6EE"/>
+              </a:solidFill>
+            </a:ln>
+          </c:spPr>
+        </c:majorGridlines>
+        <c:title>
+          <c:tx>
+            <c:rich>
+              <a:bodyPr/>
+              <a:lstStyle/>
+              <a:p>
+                <a:r>
+                  <a:rPr sz="1000" b="0">
+                    <a:solidFill>
+                      <a:srgbClr val="5A6072"/>
+                    </a:solidFill>
+                    <a:latin typeface="Calibri"/>
+                  </a:rPr>
+                  <a:t>Enterprise Value (EUR m)</a:t>
+                </a:r>
+              </a:p>
+            </c:rich>
+          </c:tx>
+          <c:layout/>
+          <c:overlay val="0"/>
+        </c:title>
+        <c:majorTickMark val="out"/>
+        <c:minorTickMark val="none"/>
+        <c:tickLblPos val="nextTo"/>
+        <c:spPr>
+          <a:ln>
+            <a:noFill/>
+          </a:ln>
+        </c:spPr>
+        <c:crossAx val="-2068027336"/>
+        <c:crosses val="autoZero"/>
+        <c:majorUnit val="200.0"/>
+      </c:valAx>
+    </c:plotArea>
+    <c:dispBlanksAs val="gap"/>
+  </c:chart>
+  <c:txPr>
+    <a:bodyPr/>
+    <a:lstStyle/>
+    <a:p>
+      <a:pPr>
+        <a:defRPr sz="1000">
+          <a:solidFill>
+            <a:srgbClr val="5A6072"/>
+          </a:solidFill>
+          <a:latin typeface="Calibri"/>
+        </a:defRPr>
+      </a:pPr>
+      <a:endParaRPr lang="en-US"/>
+    </a:p>
+  </c:txPr>
   <c:externalData r:id="rId1">
     <c:autoUpdate val="0"/>
   </c:externalData>
@@ -3995,7 +4274,7 @@
                 <a:ea typeface="Calibri" pitchFamily="34" charset="-122"/>
                 <a:cs typeface="Calibri" pitchFamily="34" charset="-120"/>
               </a:rPr>
-              <a:t>Independent Student M&amp;A Case Study  |  September 2026</a:t>
+              <a:t>Independent Student M&amp;A Case Study  |  September 2026  |  Updated 9 October 2026 for the announced sale</a:t>
             </a:r>
             <a:endParaRPr lang="en-US" sz="1300" dirty="0"/>
           </a:p>
@@ -7657,6 +7936,40 @@
           </a:p>
         </p:txBody>
       </p:sp>
+      <p:sp>
+        <p:nvSpPr>
+          <p:cNvPr id="12" name="Update note"/>
+          <p:cNvSpPr txBox="1"/>
+          <p:nvPr/>
+        </p:nvSpPr>
+        <p:spPr>
+          <a:xfrm>
+            <a:off x="548640" y="6035040"/>
+            <a:ext cx="11064240" cy="320040"/>
+          </a:xfrm>
+          <a:prstGeom prst="rect">
+            <a:avLst/>
+          </a:prstGeom>
+          <a:noFill/>
+        </p:spPr>
+        <p:txBody>
+          <a:bodyPr wrap="square" anchor="ctr">
+            <a:spAutoFit/>
+          </a:bodyPr>
+          <a:lstStyle/>
+          <a:p>
+            <a:r>
+              <a:rPr sz="1050" i="1" b="1">
+                <a:solidFill>
+                  <a:srgbClr val="1E2761"/>
+                </a:solidFill>
+                <a:latin typeface="Calibri"/>
+              </a:rPr>
+              <a:t>Update (Oct 2026): the announced deal sits between the options: one buyer, seven countries, staged closings (Indonesia first).</a:t>
+            </a:r>
+          </a:p>
+        </p:txBody>
+      </p:sp>
     </p:spTree>
   </p:cSld>
   <p:clrMapOvr>
@@ -7761,7 +8074,7 @@
                 <a:ea typeface="Cambria" pitchFamily="34" charset="-122"/>
                 <a:cs typeface="Cambria" pitchFamily="34" charset="-120"/>
               </a:rPr>
-              <a:t>Reported timeline points to non-binding offers due mid-September 2026</a:t>
+              <a:t>Reported timeline pointed to non-binding offers in mid-September; binding agreements followed on 3 October</a:t>
             </a:r>
             <a:endParaRPr lang="en-US" sz="2600" dirty="0"/>
           </a:p>
@@ -8655,7 +8968,7 @@
                 <a:ea typeface="Calibri" pitchFamily="34" charset="-122"/>
                 <a:cs typeface="Calibri" pitchFamily="34" charset="-120"/>
               </a:rPr>
-              <a:t>Not disclosed</a:t>
+              <a:t>3 Oct 2026</a:t>
             </a:r>
             <a:endParaRPr lang="en-US" sz="1050" dirty="0"/>
           </a:p>
@@ -8694,7 +9007,7 @@
                 <a:ea typeface="Cambria" pitchFamily="34" charset="-122"/>
                 <a:cs typeface="Cambria" pitchFamily="34" charset="-120"/>
               </a:rPr>
-              <a:t>Exclusivity / SPA / Close</a:t>
+              <a:t>Signing and closings</a:t>
             </a:r>
             <a:endParaRPr lang="en-US" sz="1300" dirty="0"/>
           </a:p>
@@ -8708,8 +9021,8 @@
         </p:nvSpPr>
         <p:spPr>
           <a:xfrm>
-            <a:off x="10149840" y="3429000"/>
-            <a:ext cx="2057400" cy="1280160"/>
+            <a:off x="10058400" y="3429000"/>
+            <a:ext cx="2011680" cy="1280160"/>
           </a:xfrm>
           <a:prstGeom prst="rect">
             <a:avLst/>
@@ -8733,7 +9046,7 @@
                 <a:ea typeface="Calibri" pitchFamily="34" charset="-122"/>
                 <a:cs typeface="Calibri" pitchFamily="34" charset="-120"/>
               </a:rPr>
-              <a:t>No public timeline beyond the NBO deadline</a:t>
+              <a:t>Signed 3 Oct, announced 5 Oct; Indonesia expected late 2026, rest mid-2027</a:t>
             </a:r>
             <a:endParaRPr lang="en-US" sz="1000" dirty="0"/>
           </a:p>
@@ -8766,13 +9079,13 @@
             <a:r>
               <a:rPr lang="en-US" sz="1050" i="1" dirty="0">
                 <a:solidFill>
-                  <a:srgbClr val="C00000"/>
-                </a:solidFill>
-                <a:latin typeface="Calibri" pitchFamily="34" charset="0"/>
-                <a:ea typeface="Calibri" pitchFamily="34" charset="-122"/>
-                <a:cs typeface="Calibri" pitchFamily="34" charset="-120"/>
-              </a:rPr>
-              <a:t>No signing, exclusivity or closing date is publicly disclosed beyond the reported NBO deadline. Timeline beyond mid-September 2026 is UNAVAILABLE / NOT PUBLICLY DISCLOSED.</a:t>
+                  <a:srgbClr val="1E2761"/>
+                </a:solidFill>
+                <a:latin typeface="Calibri" pitchFamily="34" charset="0"/>
+                <a:ea typeface="Calibri" pitchFamily="34" charset="-122"/>
+                <a:cs typeface="Calibri" pitchFamily="34" charset="-120"/>
+              </a:rPr>
+              <a:t>Update (9 Oct 2026): AkzoNobel announced binding agreements on 5 Oct 2026 for a seven-country sale to Nippon Paint; closings are subject to regulatory approvals. Steps 1-4 are the September reporting (ION Analytics).</a:t>
             </a:r>
             <a:endParaRPr lang="en-US" sz="1050" dirty="0"/>
           </a:p>
@@ -8811,7 +9124,7 @@
                 <a:ea typeface="Calibri" pitchFamily="34" charset="-122"/>
                 <a:cs typeface="Calibri" pitchFamily="34" charset="-120"/>
               </a:rPr>
-              <a:t>Source: ION Analytics article.</a:t>
+              <a:t>Source: ION Analytics article (steps 1-4); AkzoNobel media release, 5 Oct 2026 (SRC-037); PCI Magazine (SRC-039, signing date).</a:t>
             </a:r>
             <a:endParaRPr lang="en-US" sz="800" dirty="0"/>
           </a:p>
@@ -13237,6 +13550,1128 @@
 </p:sld>
 </file>
 
+<file path=ppt/slides/slide18.xml><?xml version="1.0" encoding="utf-8"?>
+<p:sld xmlns:a="http://schemas.openxmlformats.org/drawingml/2006/main" xmlns:p="http://schemas.openxmlformats.org/presentationml/2006/main" xmlns:r="http://schemas.openxmlformats.org/officeDocument/2006/relationships">
+  <p:cSld>
+    <p:bg>
+      <p:bgPr>
+        <a:solidFill>
+          <a:srgbClr val="FFFFFF"/>
+        </a:solidFill>
+        <a:effectLst/>
+      </p:bgPr>
+    </p:bg>
+    <p:spTree>
+      <p:nvGrpSpPr>
+        <p:cNvPr id="1" name=""/>
+        <p:cNvGrpSpPr/>
+        <p:nvPr/>
+      </p:nvGrpSpPr>
+      <p:grpSpPr/>
+      <p:sp>
+        <p:nvSpPr>
+          <p:cNvPr id="2" name="Eyebrow"/>
+          <p:cNvSpPr txBox="1"/>
+          <p:nvPr/>
+        </p:nvSpPr>
+        <p:spPr>
+          <a:xfrm>
+            <a:off x="548640" y="365760"/>
+            <a:ext cx="10972800" cy="274320"/>
+          </a:xfrm>
+          <a:prstGeom prst="rect">
+            <a:avLst/>
+          </a:prstGeom>
+          <a:noFill/>
+        </p:spPr>
+        <p:txBody>
+          <a:bodyPr wrap="square" anchor="ctr">
+            <a:spAutoFit/>
+          </a:bodyPr>
+          <a:lstStyle/>
+          <a:p>
+            <a:r>
+              <a:rPr sz="1100" b="1" i="0" spc="200">
+                <a:solidFill>
+                  <a:srgbClr val="C9A227"/>
+                </a:solidFill>
+                <a:latin typeface="Calibri"/>
+              </a:rPr>
+              <a:t>POST-ANNOUNCEMENT UPDATE</a:t>
+            </a:r>
+          </a:p>
+        </p:txBody>
+      </p:sp>
+      <p:sp>
+        <p:nvSpPr>
+          <p:cNvPr id="3" name="Title"/>
+          <p:cNvSpPr txBox="1"/>
+          <p:nvPr/>
+        </p:nvSpPr>
+        <p:spPr>
+          <a:xfrm>
+            <a:off x="548640" y="621792"/>
+            <a:ext cx="11064240" cy="822960"/>
+          </a:xfrm>
+          <a:prstGeom prst="rect">
+            <a:avLst/>
+          </a:prstGeom>
+          <a:noFill/>
+        </p:spPr>
+        <p:txBody>
+          <a:bodyPr wrap="square" anchor="ctr">
+            <a:spAutoFit/>
+          </a:bodyPr>
+          <a:lstStyle/>
+          <a:p>
+            <a:r>
+              <a:rPr sz="2600" b="1" i="0">
+                <a:solidFill>
+                  <a:srgbClr val="1E2761"/>
+                </a:solidFill>
+                <a:latin typeface="Cambria"/>
+              </a:rPr>
+              <a:t>The announced deal was wider and richer than the September case study assumed</a:t>
+            </a:r>
+          </a:p>
+        </p:txBody>
+      </p:sp>
+      <p:sp>
+        <p:nvSpPr>
+          <p:cNvPr id="4" name="Source"/>
+          <p:cNvSpPr txBox="1"/>
+          <p:nvPr/>
+        </p:nvSpPr>
+        <p:spPr>
+          <a:xfrm>
+            <a:off x="457200" y="6473952"/>
+            <a:ext cx="9601200" cy="292608"/>
+          </a:xfrm>
+          <a:prstGeom prst="rect">
+            <a:avLst/>
+          </a:prstGeom>
+          <a:noFill/>
+        </p:spPr>
+        <p:txBody>
+          <a:bodyPr wrap="square" anchor="ctr">
+            <a:spAutoFit/>
+          </a:bodyPr>
+          <a:lstStyle/>
+          <a:p>
+            <a:r>
+              <a:rPr sz="800" b="0" i="1">
+                <a:solidFill>
+                  <a:srgbClr val="5A6072"/>
+                </a:solidFill>
+                <a:latin typeface="Calibri"/>
+              </a:rPr>
+              <a:t>Source: AkzoNobel media release, 5 Oct 2026 (SRC-037); SEC Form 6-K (SRC-038); PCI Magazine (SRC-039); 02_Financial_Model; 10_Supporting_Research/Post_Announcement_Addendum.md.</a:t>
+            </a:r>
+          </a:p>
+        </p:txBody>
+      </p:sp>
+      <p:sp>
+        <p:nvSpPr>
+          <p:cNvPr id="5" name="Page number"/>
+          <p:cNvSpPr txBox="1"/>
+          <p:nvPr/>
+        </p:nvSpPr>
+        <p:spPr>
+          <a:xfrm>
+            <a:off x="11521440" y="6473952"/>
+            <a:ext cx="457200" cy="292608"/>
+          </a:xfrm>
+          <a:prstGeom prst="rect">
+            <a:avLst/>
+          </a:prstGeom>
+          <a:noFill/>
+        </p:spPr>
+        <p:txBody>
+          <a:bodyPr wrap="square" anchor="ctr">
+            <a:spAutoFit/>
+          </a:bodyPr>
+          <a:lstStyle/>
+          <a:p>
+            <a:pPr algn="r"/>
+            <a:r>
+              <a:rPr sz="900" b="0" i="0">
+                <a:solidFill>
+                  <a:srgbClr val="5A6072"/>
+                </a:solidFill>
+                <a:latin typeface="Calibri"/>
+              </a:rPr>
+              <a:t>18</a:t>
+            </a:r>
+          </a:p>
+        </p:txBody>
+      </p:sp>
+      <p:graphicFrame>
+        <p:nvGraphicFramePr>
+          <p:cNvPr id="6" name="Comparison table"/>
+          <p:cNvGraphicFramePr>
+            <a:graphicFrameLocks noGrp="1"/>
+          </p:cNvGraphicFramePr>
+          <p:nvPr/>
+        </p:nvGraphicFramePr>
+        <p:xfrm>
+          <a:off x="548640" y="1691640"/>
+          <a:ext cx="11064240" cy="4206240"/>
+        </p:xfrm>
+        <a:graphic>
+          <a:graphicData uri="http://schemas.openxmlformats.org/drawingml/2006/table">
+            <a:tbl>
+              <a:tblPr firstRow="0" bandRow="0">
+                <a:tableStyleId>{5C22544A-7EE6-4342-B048-85BDC9FD1C3A}</a:tableStyleId>
+              </a:tblPr>
+              <a:tblGrid>
+                <a:gridCol w="1828800"/>
+                <a:gridCol w="4572000"/>
+                <a:gridCol w="4663440"/>
+              </a:tblGrid>
+              <a:tr h="365760">
+                <a:tc>
+                  <a:txBody>
+                    <a:bodyPr wrap="square"/>
+                    <a:lstStyle/>
+                    <a:p>
+                      <a:r>
+                        <a:rPr sz="1100" b="1">
+                          <a:solidFill>
+                            <a:srgbClr val="FFFFFF"/>
+                          </a:solidFill>
+                          <a:latin typeface="Calibri"/>
+                        </a:rPr>
+                        <a:t>Item</a:t>
+                      </a:r>
+                    </a:p>
+                  </a:txBody>
+                  <a:tcPr anchor="ctr" marL="91440" marR="91440" marT="36576" marB="36576">
+                    <a:solidFill>
+                      <a:srgbClr val="1E2761"/>
+                    </a:solidFill>
+                  </a:tcPr>
+                </a:tc>
+                <a:tc>
+                  <a:txBody>
+                    <a:bodyPr wrap="square"/>
+                    <a:lstStyle/>
+                    <a:p>
+                      <a:r>
+                        <a:rPr sz="1100" b="1">
+                          <a:solidFill>
+                            <a:srgbClr val="FFFFFF"/>
+                          </a:solidFill>
+                          <a:latin typeface="Calibri"/>
+                        </a:rPr>
+                        <a:t>Case study (September 2026)</a:t>
+                      </a:r>
+                    </a:p>
+                  </a:txBody>
+                  <a:tcPr anchor="ctr" marL="91440" marR="91440" marT="36576" marB="36576">
+                    <a:solidFill>
+                      <a:srgbClr val="1E2761"/>
+                    </a:solidFill>
+                  </a:tcPr>
+                </a:tc>
+                <a:tc>
+                  <a:txBody>
+                    <a:bodyPr wrap="square"/>
+                    <a:lstStyle/>
+                    <a:p>
+                      <a:r>
+                        <a:rPr sz="1100" b="1">
+                          <a:solidFill>
+                            <a:srgbClr val="FFFFFF"/>
+                          </a:solidFill>
+                          <a:latin typeface="Calibri"/>
+                        </a:rPr>
+                        <a:t>Announced / reported (October 2026)</a:t>
+                      </a:r>
+                    </a:p>
+                  </a:txBody>
+                  <a:tcPr anchor="ctr" marL="91440" marR="91440" marT="36576" marB="36576">
+                    <a:solidFill>
+                      <a:srgbClr val="1E2761"/>
+                    </a:solidFill>
+                  </a:tcPr>
+                </a:tc>
+              </a:tr>
+              <a:tr h="548640">
+                <a:tc>
+                  <a:txBody>
+                    <a:bodyPr wrap="square"/>
+                    <a:lstStyle/>
+                    <a:p>
+                      <a:r>
+                        <a:rPr sz="1100" b="1">
+                          <a:solidFill>
+                            <a:srgbClr val="1E2761"/>
+                          </a:solidFill>
+                          <a:latin typeface="Calibri"/>
+                        </a:rPr>
+                        <a:t>Perimeter</a:t>
+                      </a:r>
+                    </a:p>
+                  </a:txBody>
+                  <a:tcPr anchor="ctr" marL="91440" marR="91440" marT="36576" marB="36576">
+                    <a:solidFill>
+                      <a:srgbClr val="F4F6FB"/>
+                    </a:solidFill>
+                  </a:tcPr>
+                </a:tc>
+                <a:tc>
+                  <a:txBody>
+                    <a:bodyPr wrap="square"/>
+                    <a:lstStyle/>
+                    <a:p>
+                      <a:r>
+                        <a:rPr sz="1100">
+                          <a:solidFill>
+                            <a:srgbClr val="1B1B1B"/>
+                          </a:solidFill>
+                          <a:latin typeface="Calibri"/>
+                        </a:rPr>
+                        <a:t>Four countries (Indonesia, Thailand, Malaysia, Vietnam); decorative only (analyst inference)</a:t>
+                      </a:r>
+                    </a:p>
+                  </a:txBody>
+                  <a:tcPr anchor="ctr" marL="91440" marR="91440" marT="36576" marB="36576">
+                    <a:solidFill>
+                      <a:srgbClr val="F4F6FB"/>
+                    </a:solidFill>
+                  </a:tcPr>
+                </a:tc>
+                <a:tc>
+                  <a:txBody>
+                    <a:bodyPr wrap="square"/>
+                    <a:lstStyle/>
+                    <a:p>
+                      <a:r>
+                        <a:rPr sz="1100">
+                          <a:solidFill>
+                            <a:srgbClr val="1B1B1B"/>
+                          </a:solidFill>
+                          <a:latin typeface="Calibri"/>
+                        </a:rPr>
+                        <a:t>Seven countries, adding Singapore, Papua New Guinea, Australia; decorative only; AkzoNobel keeps Coatings and Global Business Services</a:t>
+                      </a:r>
+                    </a:p>
+                  </a:txBody>
+                  <a:tcPr anchor="ctr" marL="91440" marR="91440" marT="36576" marB="36576">
+                    <a:solidFill>
+                      <a:srgbClr val="F4F6FB"/>
+                    </a:solidFill>
+                  </a:tcPr>
+                </a:tc>
+              </a:tr>
+              <a:tr h="548640">
+                <a:tc>
+                  <a:txBody>
+                    <a:bodyPr wrap="square"/>
+                    <a:lstStyle/>
+                    <a:p>
+                      <a:r>
+                        <a:rPr sz="1100" b="1">
+                          <a:solidFill>
+                            <a:srgbClr val="1E2761"/>
+                          </a:solidFill>
+                          <a:latin typeface="Calibri"/>
+                        </a:rPr>
+                        <a:t>FY2025 revenue</a:t>
+                      </a:r>
+                    </a:p>
+                  </a:txBody>
+                  <a:tcPr anchor="ctr" marL="91440" marR="91440" marT="36576" marB="36576">
+                    <a:solidFill>
+                      <a:srgbClr val="FFFFFF"/>
+                    </a:solidFill>
+                  </a:tcPr>
+                </a:tc>
+                <a:tc>
+                  <a:txBody>
+                    <a:bodyPr wrap="square"/>
+                    <a:lstStyle/>
+                    <a:p>
+                      <a:r>
+                        <a:rPr sz="1100">
+                          <a:solidFill>
+                            <a:srgbClr val="1B1B1B"/>
+                          </a:solidFill>
+                          <a:latin typeface="Calibri"/>
+                        </a:rPr>
+                        <a:t>EUR 300m anchor (ION Analytics)</a:t>
+                      </a:r>
+                    </a:p>
+                  </a:txBody>
+                  <a:tcPr anchor="ctr" marL="91440" marR="91440" marT="36576" marB="36576">
+                    <a:solidFill>
+                      <a:srgbClr val="FFFFFF"/>
+                    </a:solidFill>
+                  </a:tcPr>
+                </a:tc>
+                <a:tc>
+                  <a:txBody>
+                    <a:bodyPr wrap="square"/>
+                    <a:lstStyle/>
+                    <a:p>
+                      <a:r>
+                        <a:rPr sz="1100">
+                          <a:solidFill>
+                            <a:srgbClr val="1B1B1B"/>
+                          </a:solidFill>
+                          <a:latin typeface="Calibri"/>
+                        </a:rPr>
+                        <a:t>About EUR 259m (USD 291m), seven countries *</a:t>
+                      </a:r>
+                    </a:p>
+                  </a:txBody>
+                  <a:tcPr anchor="ctr" marL="91440" marR="91440" marT="36576" marB="36576">
+                    <a:solidFill>
+                      <a:srgbClr val="FFFFFF"/>
+                    </a:solidFill>
+                  </a:tcPr>
+                </a:tc>
+              </a:tr>
+              <a:tr h="548640">
+                <a:tc>
+                  <a:txBody>
+                    <a:bodyPr wrap="square"/>
+                    <a:lstStyle/>
+                    <a:p>
+                      <a:r>
+                        <a:rPr sz="1100" b="1">
+                          <a:solidFill>
+                            <a:srgbClr val="1E2761"/>
+                          </a:solidFill>
+                          <a:latin typeface="Calibri"/>
+                        </a:rPr>
+                        <a:t>FY2025 EBITDA</a:t>
+                      </a:r>
+                    </a:p>
+                  </a:txBody>
+                  <a:tcPr anchor="ctr" marL="91440" marR="91440" marT="36576" marB="36576">
+                    <a:solidFill>
+                      <a:srgbClr val="F4F6FB"/>
+                    </a:solidFill>
+                  </a:tcPr>
+                </a:tc>
+                <a:tc>
+                  <a:txBody>
+                    <a:bodyPr wrap="square"/>
+                    <a:lstStyle/>
+                    <a:p>
+                      <a:r>
+                        <a:rPr sz="1100">
+                          <a:solidFill>
+                            <a:srgbClr val="1B1B1B"/>
+                          </a:solidFill>
+                          <a:latin typeface="Calibri"/>
+                        </a:rPr>
+                        <a:t>EUR 47.4m (15.8% group Decorative Paints margin used as proxy)</a:t>
+                      </a:r>
+                    </a:p>
+                  </a:txBody>
+                  <a:tcPr anchor="ctr" marL="91440" marR="91440" marT="36576" marB="36576">
+                    <a:solidFill>
+                      <a:srgbClr val="F4F6FB"/>
+                    </a:solidFill>
+                  </a:tcPr>
+                </a:tc>
+                <a:tc>
+                  <a:txBody>
+                    <a:bodyPr wrap="square"/>
+                    <a:lstStyle/>
+                    <a:p>
+                      <a:r>
+                        <a:rPr sz="1100">
+                          <a:solidFill>
+                            <a:srgbClr val="1B1B1B"/>
+                          </a:solidFill>
+                          <a:latin typeface="Calibri"/>
+                        </a:rPr>
+                        <a:t>About EUR 58m (USD 65m), 22% margin *</a:t>
+                      </a:r>
+                    </a:p>
+                  </a:txBody>
+                  <a:tcPr anchor="ctr" marL="91440" marR="91440" marT="36576" marB="36576">
+                    <a:solidFill>
+                      <a:srgbClr val="F4F6FB"/>
+                    </a:solidFill>
+                  </a:tcPr>
+                </a:tc>
+              </a:tr>
+              <a:tr h="548640">
+                <a:tc>
+                  <a:txBody>
+                    <a:bodyPr wrap="square"/>
+                    <a:lstStyle/>
+                    <a:p>
+                      <a:r>
+                        <a:rPr sz="1100" b="1">
+                          <a:solidFill>
+                            <a:srgbClr val="1E2761"/>
+                          </a:solidFill>
+                          <a:latin typeface="Calibri"/>
+                        </a:rPr>
+                        <a:t>Enterprise value</a:t>
+                      </a:r>
+                    </a:p>
+                  </a:txBody>
+                  <a:tcPr anchor="ctr" marL="91440" marR="91440" marT="36576" marB="36576">
+                    <a:solidFill>
+                      <a:srgbClr val="FFFFFF"/>
+                    </a:solidFill>
+                  </a:tcPr>
+                </a:tc>
+                <a:tc>
+                  <a:txBody>
+                    <a:bodyPr wrap="square"/>
+                    <a:lstStyle/>
+                    <a:p>
+                      <a:r>
+                        <a:rPr sz="1100">
+                          <a:solidFill>
+                            <a:srgbClr val="1B1B1B"/>
+                          </a:solidFill>
+                          <a:latin typeface="Calibri"/>
+                        </a:rPr>
+                        <a:t>EUR 500-775m recommended (DCF base EUR 613m)</a:t>
+                      </a:r>
+                    </a:p>
+                  </a:txBody>
+                  <a:tcPr anchor="ctr" marL="91440" marR="91440" marT="36576" marB="36576">
+                    <a:solidFill>
+                      <a:srgbClr val="FFFFFF"/>
+                    </a:solidFill>
+                  </a:tcPr>
+                </a:tc>
+                <a:tc>
+                  <a:txBody>
+                    <a:bodyPr wrap="square"/>
+                    <a:lstStyle/>
+                    <a:p>
+                      <a:r>
+                        <a:rPr sz="1100">
+                          <a:solidFill>
+                            <a:srgbClr val="1B1B1B"/>
+                          </a:solidFill>
+                          <a:latin typeface="Calibri"/>
+                        </a:rPr>
+                        <a:t>EUR 1.20bn (USD 1.35bn)</a:t>
+                      </a:r>
+                    </a:p>
+                  </a:txBody>
+                  <a:tcPr anchor="ctr" marL="91440" marR="91440" marT="36576" marB="36576">
+                    <a:solidFill>
+                      <a:srgbClr val="FFFFFF"/>
+                    </a:solidFill>
+                  </a:tcPr>
+                </a:tc>
+              </a:tr>
+              <a:tr h="548640">
+                <a:tc>
+                  <a:txBody>
+                    <a:bodyPr wrap="square"/>
+                    <a:lstStyle/>
+                    <a:p>
+                      <a:r>
+                        <a:rPr sz="1100" b="1">
+                          <a:solidFill>
+                            <a:srgbClr val="1E2761"/>
+                          </a:solidFill>
+                          <a:latin typeface="Calibri"/>
+                        </a:rPr>
+                        <a:t>Multiple</a:t>
+                      </a:r>
+                    </a:p>
+                  </a:txBody>
+                  <a:tcPr anchor="ctr" marL="91440" marR="91440" marT="36576" marB="36576">
+                    <a:solidFill>
+                      <a:srgbClr val="F4F6FB"/>
+                    </a:solidFill>
+                  </a:tcPr>
+                </a:tc>
+                <a:tc>
+                  <a:txBody>
+                    <a:bodyPr wrap="square"/>
+                    <a:lstStyle/>
+                    <a:p>
+                      <a:r>
+                        <a:rPr sz="1100">
+                          <a:solidFill>
+                            <a:srgbClr val="1B1B1B"/>
+                          </a:solidFill>
+                          <a:latin typeface="Calibri"/>
+                        </a:rPr>
+                        <a:t>Mid-point implies ~10.8x FY25 EBITDA and ~2.4x revenue on the reported figures</a:t>
+                      </a:r>
+                    </a:p>
+                  </a:txBody>
+                  <a:tcPr anchor="ctr" marL="91440" marR="91440" marT="36576" marB="36576">
+                    <a:solidFill>
+                      <a:srgbClr val="F4F6FB"/>
+                    </a:solidFill>
+                  </a:tcPr>
+                </a:tc>
+                <a:tc>
+                  <a:txBody>
+                    <a:bodyPr wrap="square"/>
+                    <a:lstStyle/>
+                    <a:p>
+                      <a:r>
+                        <a:rPr sz="1100">
+                          <a:solidFill>
+                            <a:srgbClr val="1B1B1B"/>
+                          </a:solidFill>
+                          <a:latin typeface="Calibri"/>
+                        </a:rPr>
+                        <a:t>21x FY25 EBITDA (about 16x 2026E per Nippon Paint *); ~4.6x FY25 revenue</a:t>
+                      </a:r>
+                    </a:p>
+                  </a:txBody>
+                  <a:tcPr anchor="ctr" marL="91440" marR="91440" marT="36576" marB="36576">
+                    <a:solidFill>
+                      <a:srgbClr val="F4F6FB"/>
+                    </a:solidFill>
+                  </a:tcPr>
+                </a:tc>
+              </a:tr>
+              <a:tr h="548640">
+                <a:tc>
+                  <a:txBody>
+                    <a:bodyPr wrap="square"/>
+                    <a:lstStyle/>
+                    <a:p>
+                      <a:r>
+                        <a:rPr sz="1100" b="1">
+                          <a:solidFill>
+                            <a:srgbClr val="1E2761"/>
+                          </a:solidFill>
+                          <a:latin typeface="Calibri"/>
+                        </a:rPr>
+                        <a:t>Buyer</a:t>
+                      </a:r>
+                    </a:p>
+                  </a:txBody>
+                  <a:tcPr anchor="ctr" marL="91440" marR="91440" marT="36576" marB="36576">
+                    <a:solidFill>
+                      <a:srgbClr val="FFFFFF"/>
+                    </a:solidFill>
+                  </a:tcPr>
+                </a:tc>
+                <a:tc>
+                  <a:txBody>
+                    <a:bodyPr wrap="square"/>
+                    <a:lstStyle/>
+                    <a:p>
+                      <a:r>
+                        <a:rPr sz="1100">
+                          <a:solidFill>
+                            <a:srgbClr val="1B1B1B"/>
+                          </a:solidFill>
+                          <a:latin typeface="Calibri"/>
+                        </a:rPr>
+                        <a:t>Nippon Paint: strongest fit and highest regulatory risk; SCG in preliminary talks</a:t>
+                      </a:r>
+                    </a:p>
+                  </a:txBody>
+                  <a:tcPr anchor="ctr" marL="91440" marR="91440" marT="36576" marB="36576">
+                    <a:solidFill>
+                      <a:srgbClr val="FFFFFF"/>
+                    </a:solidFill>
+                  </a:tcPr>
+                </a:tc>
+                <a:tc>
+                  <a:txBody>
+                    <a:bodyPr wrap="square"/>
+                    <a:lstStyle/>
+                    <a:p>
+                      <a:r>
+                        <a:rPr sz="1100">
+                          <a:solidFill>
+                            <a:srgbClr val="1B1B1B"/>
+                          </a:solidFill>
+                          <a:latin typeface="Calibri"/>
+                        </a:rPr>
+                        <a:t>Nippon Paint; regulatory approvals are closing conditions; SCG not mentioned</a:t>
+                      </a:r>
+                    </a:p>
+                  </a:txBody>
+                  <a:tcPr anchor="ctr" marL="91440" marR="91440" marT="36576" marB="36576">
+                    <a:solidFill>
+                      <a:srgbClr val="FFFFFF"/>
+                    </a:solidFill>
+                  </a:tcPr>
+                </a:tc>
+              </a:tr>
+              <a:tr h="548640">
+                <a:tc>
+                  <a:txBody>
+                    <a:bodyPr wrap="square"/>
+                    <a:lstStyle/>
+                    <a:p>
+                      <a:r>
+                        <a:rPr sz="1100" b="1">
+                          <a:solidFill>
+                            <a:srgbClr val="1E2761"/>
+                          </a:solidFill>
+                          <a:latin typeface="Calibri"/>
+                        </a:rPr>
+                        <a:t>Timeline</a:t>
+                      </a:r>
+                    </a:p>
+                  </a:txBody>
+                  <a:tcPr anchor="ctr" marL="91440" marR="91440" marT="36576" marB="36576">
+                    <a:solidFill>
+                      <a:srgbClr val="F4F6FB"/>
+                    </a:solidFill>
+                  </a:tcPr>
+                </a:tc>
+                <a:tc>
+                  <a:txBody>
+                    <a:bodyPr wrap="square"/>
+                    <a:lstStyle/>
+                    <a:p>
+                      <a:r>
+                        <a:rPr sz="1100">
+                          <a:solidFill>
+                            <a:srgbClr val="1B1B1B"/>
+                          </a:solidFill>
+                          <a:latin typeface="Calibri"/>
+                        </a:rPr>
+                        <a:t>Non-binding offers mid-Sep 2026; nothing known after</a:t>
+                      </a:r>
+                    </a:p>
+                  </a:txBody>
+                  <a:tcPr anchor="ctr" marL="91440" marR="91440" marT="36576" marB="36576">
+                    <a:solidFill>
+                      <a:srgbClr val="F4F6FB"/>
+                    </a:solidFill>
+                  </a:tcPr>
+                </a:tc>
+                <a:tc>
+                  <a:txBody>
+                    <a:bodyPr wrap="square"/>
+                    <a:lstStyle/>
+                    <a:p>
+                      <a:r>
+                        <a:rPr sz="1100">
+                          <a:solidFill>
+                            <a:srgbClr val="1B1B1B"/>
+                          </a:solidFill>
+                          <a:latin typeface="Calibri"/>
+                        </a:rPr>
+                        <a:t>Signed 3 Oct, announced 5 Oct 2026; Indonesia closes late 2026, rest mid-2027</a:t>
+                      </a:r>
+                    </a:p>
+                  </a:txBody>
+                  <a:tcPr anchor="ctr" marL="91440" marR="91440" marT="36576" marB="36576">
+                    <a:solidFill>
+                      <a:srgbClr val="F4F6FB"/>
+                    </a:solidFill>
+                  </a:tcPr>
+                </a:tc>
+              </a:tr>
+            </a:tbl>
+          </a:graphicData>
+        </a:graphic>
+      </p:graphicFrame>
+      <p:sp>
+        <p:nvSpPr>
+          <p:cNvPr id="7" name="Footnote"/>
+          <p:cNvSpPr txBox="1"/>
+          <p:nvPr/>
+        </p:nvSpPr>
+        <p:spPr>
+          <a:xfrm>
+            <a:off x="548640" y="5989320"/>
+            <a:ext cx="11064240" cy="411480"/>
+          </a:xfrm>
+          <a:prstGeom prst="rect">
+            <a:avLst/>
+          </a:prstGeom>
+          <a:noFill/>
+        </p:spPr>
+        <p:txBody>
+          <a:bodyPr wrap="square" anchor="ctr">
+            <a:spAutoFit/>
+          </a:bodyPr>
+          <a:lstStyle/>
+          <a:p>
+            <a:r>
+              <a:rPr sz="1000" b="0" i="1">
+                <a:solidFill>
+                  <a:srgbClr val="5A6072"/>
+                </a:solidFill>
+                <a:latin typeface="Calibri"/>
+              </a:rPr>
+              <a:t>* Single-source trade-press figures (PCI Magazine); not stated in AkzoNobel's release. EUR at the release-implied USD 1.125 per EUR. The September model and valuation have not been re-run on the announced deal.</a:t>
+            </a:r>
+          </a:p>
+        </p:txBody>
+      </p:sp>
+    </p:spTree>
+  </p:cSld>
+  <p:clrMapOvr>
+    <a:masterClrMapping/>
+  </p:clrMapOvr>
+</p:sld>
+</file>
+
+<file path=ppt/slides/slide19.xml><?xml version="1.0" encoding="utf-8"?>
+<p:sld xmlns:a="http://schemas.openxmlformats.org/drawingml/2006/main" xmlns:p="http://schemas.openxmlformats.org/presentationml/2006/main" xmlns:r="http://schemas.openxmlformats.org/officeDocument/2006/relationships">
+  <p:cSld>
+    <p:bg>
+      <p:bgPr>
+        <a:solidFill>
+          <a:srgbClr val="FFFFFF"/>
+        </a:solidFill>
+        <a:effectLst/>
+      </p:bgPr>
+    </p:bg>
+    <p:spTree>
+      <p:nvGrpSpPr>
+        <p:cNvPr id="1" name=""/>
+        <p:cNvGrpSpPr/>
+        <p:nvPr/>
+      </p:nvGrpSpPr>
+      <p:grpSpPr/>
+      <p:sp>
+        <p:nvSpPr>
+          <p:cNvPr id="2" name="Eyebrow"/>
+          <p:cNvSpPr txBox="1"/>
+          <p:nvPr/>
+        </p:nvSpPr>
+        <p:spPr>
+          <a:xfrm>
+            <a:off x="548640" y="365760"/>
+            <a:ext cx="10972800" cy="274320"/>
+          </a:xfrm>
+          <a:prstGeom prst="rect">
+            <a:avLst/>
+          </a:prstGeom>
+          <a:noFill/>
+        </p:spPr>
+        <p:txBody>
+          <a:bodyPr wrap="square" anchor="ctr">
+            <a:spAutoFit/>
+          </a:bodyPr>
+          <a:lstStyle/>
+          <a:p>
+            <a:r>
+              <a:rPr sz="1100" b="1" i="0" spc="200">
+                <a:solidFill>
+                  <a:srgbClr val="C9A227"/>
+                </a:solidFill>
+                <a:latin typeface="Calibri"/>
+              </a:rPr>
+              <a:t>VALUATION BACK-TEST</a:t>
+            </a:r>
+          </a:p>
+        </p:txBody>
+      </p:sp>
+      <p:sp>
+        <p:nvSpPr>
+          <p:cNvPr id="3" name="Title"/>
+          <p:cNvSpPr txBox="1"/>
+          <p:nvPr/>
+        </p:nvSpPr>
+        <p:spPr>
+          <a:xfrm>
+            <a:off x="548640" y="621792"/>
+            <a:ext cx="11064240" cy="822960"/>
+          </a:xfrm>
+          <a:prstGeom prst="rect">
+            <a:avLst/>
+          </a:prstGeom>
+          <a:noFill/>
+        </p:spPr>
+        <p:txBody>
+          <a:bodyPr wrap="square" anchor="ctr">
+            <a:spAutoFit/>
+          </a:bodyPr>
+          <a:lstStyle/>
+          <a:p>
+            <a:r>
+              <a:rPr sz="2600" b="1" i="0">
+                <a:solidFill>
+                  <a:srgbClr val="1E2761"/>
+                </a:solidFill>
+                <a:latin typeface="Cambria"/>
+              </a:rPr>
+              <a:t>The announced price is 55% above the recommended range; EBITDA comps were the method that bracketed it</a:t>
+            </a:r>
+          </a:p>
+        </p:txBody>
+      </p:sp>
+      <p:sp>
+        <p:nvSpPr>
+          <p:cNvPr id="4" name="Source"/>
+          <p:cNvSpPr txBox="1"/>
+          <p:nvPr/>
+        </p:nvSpPr>
+        <p:spPr>
+          <a:xfrm>
+            <a:off x="457200" y="6473952"/>
+            <a:ext cx="9601200" cy="292608"/>
+          </a:xfrm>
+          <a:prstGeom prst="rect">
+            <a:avLst/>
+          </a:prstGeom>
+          <a:noFill/>
+        </p:spPr>
+        <p:txBody>
+          <a:bodyPr wrap="square" anchor="ctr">
+            <a:spAutoFit/>
+          </a:bodyPr>
+          <a:lstStyle/>
+          <a:p>
+            <a:r>
+              <a:rPr sz="800" b="0" i="1">
+                <a:solidFill>
+                  <a:srgbClr val="5A6072"/>
+                </a:solidFill>
+                <a:latin typeface="Calibri"/>
+              </a:rPr>
+              <a:t>Source: Post_Announcement_Addendum.md; 05_Valuation; 03_Trading_Comps; SRC-037; SRC-039. * P25-P75 comps multiples applied to reported FY25 EBITDA/revenue; USD to EUR at 1.125.</a:t>
+            </a:r>
+          </a:p>
+        </p:txBody>
+      </p:sp>
+      <p:sp>
+        <p:nvSpPr>
+          <p:cNvPr id="5" name="Page number"/>
+          <p:cNvSpPr txBox="1"/>
+          <p:nvPr/>
+        </p:nvSpPr>
+        <p:spPr>
+          <a:xfrm>
+            <a:off x="11521440" y="6473952"/>
+            <a:ext cx="457200" cy="292608"/>
+          </a:xfrm>
+          <a:prstGeom prst="rect">
+            <a:avLst/>
+          </a:prstGeom>
+          <a:noFill/>
+        </p:spPr>
+        <p:txBody>
+          <a:bodyPr wrap="square" anchor="ctr">
+            <a:spAutoFit/>
+          </a:bodyPr>
+          <a:lstStyle/>
+          <a:p>
+            <a:pPr algn="r"/>
+            <a:r>
+              <a:rPr sz="900" b="0" i="0">
+                <a:solidFill>
+                  <a:srgbClr val="5A6072"/>
+                </a:solidFill>
+                <a:latin typeface="Calibri"/>
+              </a:rPr>
+              <a:t>19</a:t>
+            </a:r>
+          </a:p>
+        </p:txBody>
+      </p:sp>
+      <p:graphicFrame>
+        <p:nvGraphicFramePr>
+          <p:cNvPr id="6" name="Back-test chart"/>
+          <p:cNvGraphicFramePr>
+            <a:graphicFrameLocks noGrp="1"/>
+          </p:cNvGraphicFramePr>
+          <p:nvPr/>
+        </p:nvGraphicFramePr>
+        <p:xfrm>
+          <a:off x="548640" y="1737360"/>
+          <a:ext cx="7498079" cy="4114800"/>
+        </p:xfrm>
+        <a:graphic>
+          <a:graphicData uri="http://schemas.openxmlformats.org/drawingml/2006/chart">
+            <c:chart xmlns:c="http://schemas.openxmlformats.org/drawingml/2006/chart" r:id="rId2"/>
+          </a:graphicData>
+        </a:graphic>
+      </p:graphicFrame>
+      <p:sp>
+        <p:nvSpPr>
+          <p:cNvPr id="7" name="Panel label"/>
+          <p:cNvSpPr txBox="1"/>
+          <p:nvPr/>
+        </p:nvSpPr>
+        <p:spPr>
+          <a:xfrm>
+            <a:off x="8321040" y="1783080"/>
+            <a:ext cx="3291840" cy="320040"/>
+          </a:xfrm>
+          <a:prstGeom prst="rect">
+            <a:avLst/>
+          </a:prstGeom>
+          <a:noFill/>
+        </p:spPr>
+        <p:txBody>
+          <a:bodyPr wrap="square" anchor="ctr">
+            <a:spAutoFit/>
+          </a:bodyPr>
+          <a:lstStyle/>
+          <a:p>
+            <a:r>
+              <a:rPr sz="1200" b="0" i="0">
+                <a:solidFill>
+                  <a:srgbClr val="5A6072"/>
+                </a:solidFill>
+                <a:latin typeface="Calibri"/>
+              </a:rPr>
+              <a:t>Announced enterprise value</a:t>
+            </a:r>
+          </a:p>
+        </p:txBody>
+      </p:sp>
+      <p:sp>
+        <p:nvSpPr>
+          <p:cNvPr id="8" name="Panel stat"/>
+          <p:cNvSpPr txBox="1"/>
+          <p:nvPr/>
+        </p:nvSpPr>
+        <p:spPr>
+          <a:xfrm>
+            <a:off x="8321040" y="2057400"/>
+            <a:ext cx="3291840" cy="594360"/>
+          </a:xfrm>
+          <a:prstGeom prst="rect">
+            <a:avLst/>
+          </a:prstGeom>
+          <a:noFill/>
+        </p:spPr>
+        <p:txBody>
+          <a:bodyPr wrap="square" anchor="ctr">
+            <a:spAutoFit/>
+          </a:bodyPr>
+          <a:lstStyle/>
+          <a:p>
+            <a:r>
+              <a:rPr sz="2600" b="1" i="0">
+                <a:solidFill>
+                  <a:srgbClr val="1E2761"/>
+                </a:solidFill>
+                <a:latin typeface="Cambria"/>
+              </a:rPr>
+              <a:t>EUR 1.20bn</a:t>
+            </a:r>
+          </a:p>
+        </p:txBody>
+      </p:sp>
+      <p:sp>
+        <p:nvSpPr>
+          <p:cNvPr id="9" name="Panel sub"/>
+          <p:cNvSpPr txBox="1"/>
+          <p:nvPr/>
+        </p:nvSpPr>
+        <p:spPr>
+          <a:xfrm>
+            <a:off x="8321040" y="2606040"/>
+            <a:ext cx="3291840" cy="365760"/>
+          </a:xfrm>
+          <a:prstGeom prst="rect">
+            <a:avLst/>
+          </a:prstGeom>
+          <a:noFill/>
+        </p:spPr>
+        <p:txBody>
+          <a:bodyPr wrap="square" anchor="ctr">
+            <a:spAutoFit/>
+          </a:bodyPr>
+          <a:lstStyle/>
+          <a:p>
+            <a:r>
+              <a:rPr sz="1100" b="0" i="0">
+                <a:solidFill>
+                  <a:srgbClr val="5A6072"/>
+                </a:solidFill>
+                <a:latin typeface="Calibri"/>
+              </a:rPr>
+              <a:t>21x FY25 EBITDA  |  USD 1.35bn</a:t>
+            </a:r>
+          </a:p>
+        </p:txBody>
+      </p:sp>
+      <p:sp>
+        <p:nvSpPr>
+          <p:cNvPr id="10" name="Panel text"/>
+          <p:cNvSpPr txBox="1"/>
+          <p:nvPr/>
+        </p:nvSpPr>
+        <p:spPr>
+          <a:xfrm>
+            <a:off x="8321040" y="3108960"/>
+            <a:ext cx="3291840" cy="2743200"/>
+          </a:xfrm>
+          <a:prstGeom prst="rect">
+            <a:avLst/>
+          </a:prstGeom>
+          <a:noFill/>
+        </p:spPr>
+        <p:txBody>
+          <a:bodyPr wrap="square" anchor="t">
+            <a:spAutoFit/>
+          </a:bodyPr>
+          <a:lstStyle/>
+          <a:p>
+            <a:pPr>
+              <a:spcAft>
+                <a:spcPts val="800"/>
+              </a:spcAft>
+            </a:pPr>
+            <a:r>
+              <a:rPr sz="1100">
+                <a:solidFill>
+                  <a:srgbClr val="1B1B1B"/>
+                </a:solidFill>
+                <a:latin typeface="Calibri"/>
+              </a:rPr>
+              <a:t>1.55x the top of the recommended range and about 1.9x its mid-point (EUR 625m).</a:t>
+            </a:r>
+          </a:p>
+          <a:p>
+            <a:pPr>
+              <a:spcAft>
+                <a:spcPts val="800"/>
+              </a:spcAft>
+            </a:pPr>
+            <a:r>
+              <a:rPr sz="1100">
+                <a:solidFill>
+                  <a:srgbClr val="1B1B1B"/>
+                </a:solidFill>
+                <a:latin typeface="Calibri"/>
+              </a:rPr>
+              <a:t>The EV/EBITDA comps range (10.3x-26.2x) brackets the deal's 20.8x. The DCF range and the revenue-based comps do not.</a:t>
+            </a:r>
+          </a:p>
+          <a:p>
+            <a:pPr>
+              <a:spcAft>
+                <a:spcPts val="800"/>
+              </a:spcAft>
+            </a:pPr>
+            <a:r>
+              <a:rPr sz="1100">
+                <a:solidFill>
+                  <a:srgbClr val="1B1B1B"/>
+                </a:solidFill>
+                <a:latin typeface="Calibri"/>
+              </a:rPr>
+              <a:t>The back-test applies September multiples to single-source FY25 figures; the price includes buyer synergies that comps do not capture.</a:t>
+            </a:r>
+          </a:p>
+        </p:txBody>
+      </p:sp>
+    </p:spTree>
+  </p:cSld>
+  <p:clrMapOvr>
+    <a:masterClrMapping/>
+  </p:clrMapOvr>
+</p:sld>
+</file>
+
 <file path=ppt/slides/slide2.xml><?xml version="1.0" encoding="utf-8"?>
 <p:sld xmlns:a="http://schemas.openxmlformats.org/drawingml/2006/main" xmlns:r="http://schemas.openxmlformats.org/officeDocument/2006/relationships" xmlns:p="http://schemas.openxmlformats.org/presentationml/2006/main">
   <p:cSld name="Slide 2">
@@ -13333,7 +14768,7 @@
                 <a:ea typeface="Cambria" pitchFamily="34" charset="-122"/>
                 <a:cs typeface="Cambria" pitchFamily="34" charset="-120"/>
               </a:rPr>
-              <a:t>AkzoNobel reviews a sale of its EUR300m Southeast Asia decorative paints platform</a:t>
+              <a:t>AkzoNobel reviewed a sale of its Southeast Asia decorative paints platform; Nippon Paint agreed to buy it</a:t>
             </a:r>
             <a:endParaRPr lang="en-US" sz="2600" dirty="0"/>
           </a:p>
@@ -13687,7 +15122,18 @@
                 <a:ea typeface="Calibri" pitchFamily="34" charset="-122"/>
                 <a:cs typeface="Calibri" pitchFamily="34" charset="-120"/>
               </a:rPr>
-              <a:t>Decorative paints operations across Indonesia, Thailand, Malaysia, Vietnam</a:t>
+              <a:t>Decorative paints operations across Indonesia, Thailand, Malaysia, Vietnam (as reported, Sep-2026)</a:t>
+            </a:r>
+            <a:r>
+              <a:rPr lang="en-US" sz="1200" dirty="0" b="1" i="0">
+                <a:solidFill>
+                  <a:srgbClr val="1E2761"/>
+                </a:solidFill>
+                <a:latin typeface="Calibri" pitchFamily="34" charset="0"/>
+                <a:ea typeface="Calibri" pitchFamily="34" charset="-122"/>
+                <a:cs typeface="Calibri" pitchFamily="34" charset="-120"/>
+              </a:rPr>
+              <a:t>  |  UPDATE: announced perimeter is seven countries; adds Singapore, Papua New Guinea, Australia</a:t>
             </a:r>
             <a:endParaRPr lang="en-US" sz="1200" dirty="0"/>
           </a:p>
@@ -13807,6 +15253,17 @@
               </a:rPr>
               <a:t>EUR 300m (~USD 346m) annual, per ION Analytics</a:t>
             </a:r>
+            <a:r>
+              <a:rPr lang="en-US" sz="1200" dirty="0" b="1" i="0">
+                <a:solidFill>
+                  <a:srgbClr val="1E2761"/>
+                </a:solidFill>
+                <a:latin typeface="Calibri" pitchFamily="34" charset="0"/>
+                <a:ea typeface="Calibri" pitchFamily="34" charset="-122"/>
+                <a:cs typeface="Calibri" pitchFamily="34" charset="-120"/>
+              </a:rPr>
+              <a:t>  |  UPDATE: reported FY25 revenue ~USD 291m, EBITDA ~USD 65m (trade press, single source)</a:t>
+            </a:r>
             <a:endParaRPr lang="en-US" sz="1200" dirty="0"/>
           </a:p>
         </p:txBody>
@@ -13925,6 +15382,17 @@
               </a:rPr>
               <a:t>CEO flagged review Apr-2026; non-binding offers reported due mid-Sep-2026</a:t>
             </a:r>
+            <a:r>
+              <a:rPr lang="en-US" sz="1200" dirty="0" b="1" i="0">
+                <a:solidFill>
+                  <a:srgbClr val="1E2761"/>
+                </a:solidFill>
+                <a:latin typeface="Calibri" pitchFamily="34" charset="0"/>
+                <a:ea typeface="Calibri" pitchFamily="34" charset="-122"/>
+                <a:cs typeface="Calibri" pitchFamily="34" charset="-120"/>
+              </a:rPr>
+              <a:t>  |  UPDATE: signed 3 Oct, announced 5 Oct 2026; Indonesia closes late 2026, rest mid-2027</a:t>
+            </a:r>
             <a:endParaRPr lang="en-US" sz="1200" dirty="0"/>
           </a:p>
         </p:txBody>
@@ -14043,6 +15511,17 @@
               </a:rPr>
               <a:t>May be sold as one region-wide platform, or country-by-country to local players</a:t>
             </a:r>
+            <a:r>
+              <a:rPr lang="en-US" sz="1200" dirty="0" b="1" i="0">
+                <a:solidFill>
+                  <a:srgbClr val="1E2761"/>
+                </a:solidFill>
+                <a:latin typeface="Calibri" pitchFamily="34" charset="0"/>
+                <a:ea typeface="Calibri" pitchFamily="34" charset="-122"/>
+                <a:cs typeface="Calibri" pitchFamily="34" charset="-120"/>
+              </a:rPr>
+              <a:t>  |  UPDATE: one package to a single buyer, with staged closings</a:t>
+            </a:r>
             <a:endParaRPr lang="en-US" sz="1200" dirty="0"/>
           </a:p>
         </p:txBody>
@@ -14161,6 +15640,17 @@
               </a:rPr>
               <a:t>Siam Cement Group (SCG) reported in preliminary discussions</a:t>
             </a:r>
+            <a:r>
+              <a:rPr lang="en-US" sz="1200" dirty="0" b="1" i="0">
+                <a:solidFill>
+                  <a:srgbClr val="1E2761"/>
+                </a:solidFill>
+                <a:latin typeface="Calibri" pitchFamily="34" charset="0"/>
+                <a:ea typeface="Calibri" pitchFamily="34" charset="-122"/>
+                <a:cs typeface="Calibri" pitchFamily="34" charset="-120"/>
+              </a:rPr>
+              <a:t>  |  UPDATE: buyer is Nippon Paint; EV ~USD 1.35bn (EUR 1.20bn), 21x FY25 EBITDA</a:t>
+            </a:r>
             <a:endParaRPr lang="en-US" sz="1200" dirty="0"/>
           </a:p>
         </p:txBody>
@@ -14198,7 +15688,7 @@
                 <a:ea typeface="Calibri" pitchFamily="34" charset="-122"/>
                 <a:cs typeface="Calibri" pitchFamily="34" charset="-120"/>
               </a:rPr>
-              <a:t>Source: ION Analytics/Mergermarket, 'AkzoNobel taps Goldman Sachs for sale of Southeast Asia paints assets' (SRC-001). See 01_Source_Data/Transaction_Research.md.</a:t>
+              <a:t>Source: ION Analytics/Mergermarket, 'AkzoNobel taps Goldman Sachs for sale of Southeast Asia paints assets' (SRC-001). See 01_Source_Data/Transaction_Research.md.  Update: SRC-037, SRC-039.</a:t>
             </a:r>
             <a:endParaRPr lang="en-US" sz="800" dirty="0"/>
           </a:p>
@@ -15114,7 +16604,7 @@
                 <a:ea typeface="Cambria" pitchFamily="34" charset="-122"/>
                 <a:cs typeface="Cambria" pitchFamily="34" charset="-120"/>
               </a:rPr>
-              <a:t>Confirmed decorative-paints legal entities and manufacturing sites across all four markets</a:t>
+              <a:t>Four modelled markets have confirmed entities and sites; the announced perimeter spans seven</a:t>
             </a:r>
             <a:endParaRPr lang="en-US" sz="2600" dirty="0"/>
           </a:p>
@@ -16102,6 +17592,17 @@
                 <a:cs typeface="Calibri" pitchFamily="34" charset="-120"/>
               </a:rPr>
               <a:t>Perimeter note: each market also hosts separate AkzoNobel Performance Coatings (industrial/powder) sites judged, as an analyst inference, to sit OUTSIDE the reported decorative-paints perimeter — see 01_Source_Data/SEA_Asset_Perimeter.xlsx.</a:t>
+            </a:r>
+            <a:r>
+              <a:rPr lang="en-US" sz="1050" i="0" dirty="0" b="1">
+                <a:solidFill>
+                  <a:srgbClr val="1E2761"/>
+                </a:solidFill>
+                <a:latin typeface="Calibri" pitchFamily="34" charset="0"/>
+                <a:ea typeface="Calibri" pitchFamily="34" charset="-122"/>
+                <a:cs typeface="Calibri" pitchFamily="34" charset="-120"/>
+              </a:rPr>
+              <a:t>  UPDATE (Oct 2026): the announced perimeter is decorative paints in seven countries, adding Singapore, Papua New Guinea and Australia; the Malaysia site is still to be verified.</a:t>
             </a:r>
             <a:endParaRPr lang="en-US" sz="1050" dirty="0"/>
           </a:p>

</xml_diff>

<commit_message>
Fix v2 Cases-sheet block overlap, correct source attribution and financials wording
Cases sheet: three case blocks overlapped (26-row spacing, 28 rows needed), overwriting
labels and leaving header text in the Base/Buyer 'terminal growth needed' cells, which
Deal_Check had pasted. Re-laid out at 31-row spacing; valuation workbook rebuilt with a
scripted pasted-value check. SRC-041 to SRC-043 re-read and corrected (Yahoo SG does not
attribute the figures to a press release). FY24/FY25 financials re-worded from
single-source to reported by several outlets, attributed to Nippon Paint; the 2026
projection stays single-source. Deck slides 2, 18, 19 edited and PDF re-exported.
No result changed. QC Addendum G added.

Co-Authored-By: Claude Sonnet 5.5 <noreply@anthropic.com>
</commit_message>
<xml_diff>
--- a/07_Pitch_Deck/Project_Southeast_Asia_Sell_Side_Pitch.pptx
+++ b/07_Pitch_Deck/Project_Southeast_Asia_Sell_Side_Pitch.pptx
@@ -14305,7 +14305,7 @@
                 </a:solidFill>
                 <a:latin typeface="Calibri"/>
               </a:rPr>
-              <a:t>* Single-source trade-press figures (PCI Magazine); not stated in AkzoNobel's release. EUR at the release-implied USD 1.125 per EUR. The September model and valuation have not been re-run on the announced deal.</a:t>
+              <a:t>* Reported by several outlets, attributed to Nippon Paint; primary Nippon Paint release not read; not in AkzoNobel's release. EUR at the release-implied USD 1.125 per EUR. The September model and valuation have not been re-run on the announced deal.</a:t>
             </a:r>
           </a:p>
         </p:txBody>
@@ -14659,7 +14659,7 @@
                 </a:solidFill>
                 <a:latin typeface="Calibri"/>
               </a:rPr>
-              <a:t>The back-test applies September multiples to single-source FY25 figures; the price includes buyer synergies that comps do not capture.</a:t>
+              <a:t>The back-test applies September multiples to reported FY25 figures (attributed to Nippon Paint; primary release not read); the price includes buyer synergies that comps do not capture.</a:t>
             </a:r>
           </a:p>
         </p:txBody>
@@ -15262,7 +15262,7 @@
                 <a:ea typeface="Calibri" pitchFamily="34" charset="-122"/>
                 <a:cs typeface="Calibri" pitchFamily="34" charset="-120"/>
               </a:rPr>
-              <a:t>  |  UPDATE: reported FY25 revenue ~USD 291m, EBITDA ~USD 65m (trade press, single source)</a:t>
+              <a:t>  |  UPDATE: reported FY25 revenue ~USD 291m, EBITDA ~USD 65m (several outlets, attributed to Nippon Paint)</a:t>
             </a:r>
             <a:endParaRPr lang="en-US" sz="1200" dirty="0"/>
           </a:p>

</xml_diff>